<commit_message>
Polish data flow and add demo dialogue
</commit_message>
<xml_diff>
--- a/Product Docs/InvestigateIQ_Product_Presentation.pptx
+++ b/Product Docs/InvestigateIQ_Product_Presentation.pptx
@@ -1217,7 +1217,7 @@
           <a:p>
             <a:r>
               <a:rPr lang="en-US" dirty="0"/>
-              <a:t>Soumya uses 55 seconds. Explain the flow left to right. The real implementation contains five evidence-gathering specialists plus an Investigation Summary Agent. Only the Summary Agent calls the optional Gemini model; calculated mode has no model call. The Grounding Validator checks known source IDs, selected ratio wording, forbidden verdict language, and obvious prompt-like source text. It reduces selected hallucination risks but cannot guarantee truth. Do not call these CEO or CFO agents.</a:t>
+              <a:t>Soumya uses 55 seconds. Point to the upper row first: a selected case loads stored fictional evidence, the specialist components build structured inputs, the Summary Agent optionally drafts, the validator checks selected claims, and a human records the action. Then point to the lower row: OKF guidance is chunked, FTS5/BM25 retrieves lexical matches, and exact cited chunks return to the report. Say clearly that retrieval is not proof, the validator reduces selected risks but cannot guarantee truth, and no action is automated.</a:t>
             </a:r>
             <a:endParaRPr lang="en-US" dirty="0"/>
           </a:p>
@@ -7319,91 +7319,39 @@
           <a:chExt cx="0" cy="0"/>
         </a:xfrm>
       </p:grpSpPr>
-      <p:sp>
-        <p:nvSpPr>
-          <p:cNvPr id="2" name="Text 0"/>
-          <p:cNvSpPr txBox="1"/>
-          <p:nvPr/>
-        </p:nvSpPr>
-        <p:spPr>
-          <a:xfrm>
-            <a:off x="621792" y="365760"/>
-            <a:ext cx="5486400" cy="164592"/>
-          </a:xfrm>
-          <a:prstGeom prst="rect">
-            <a:avLst/>
-          </a:prstGeom>
-          <a:noFill/>
-          <a:ln/>
-        </p:spPr>
-        <p:txBody>
-          <a:bodyPr wrap="square" lIns="0" tIns="0" rIns="0" bIns="0" rtlCol="0" anchor="ctr">
-            <a:normAutofit/>
-          </a:bodyPr>
-          <a:lstStyle/>
-          <a:p>
-            <a:pPr algn="l" indent="0" marL="0">
-              <a:buNone/>
-            </a:pPr>
-            <a:r>
-              <a:rPr lang="en-US" sz="1000" b="1" dirty="0">
-                <a:solidFill>
-                  <a:srgbClr val="00A79D"/>
-                </a:solidFill>
-                <a:latin typeface="Arial" pitchFamily="34" charset="0"/>
-                <a:ea typeface="Arial" pitchFamily="34" charset="-122"/>
-                <a:cs typeface="Arial" pitchFamily="34" charset="-120"/>
-              </a:rPr>
-              <a:t>ARCHITECTURE: TECHNOLOGY, AI, AND GUARDRAILS</a:t>
-            </a:r>
-            <a:endParaRPr lang="en-US" sz="1000" dirty="0"/>
-          </a:p>
-        </p:txBody>
-      </p:sp>
-      <p:sp>
-        <p:nvSpPr>
-          <p:cNvPr id="3" name="Text 1"/>
-          <p:cNvSpPr txBox="1"/>
-          <p:nvPr/>
-        </p:nvSpPr>
-        <p:spPr>
-          <a:xfrm>
-            <a:off x="621792" y="640080"/>
-            <a:ext cx="10972800" cy="438912"/>
-          </a:xfrm>
-          <a:prstGeom prst="rect">
-            <a:avLst/>
-          </a:prstGeom>
-          <a:noFill/>
-          <a:ln/>
-        </p:spPr>
-        <p:txBody>
-          <a:bodyPr wrap="square" lIns="0" tIns="0" rIns="0" bIns="0" rtlCol="0" anchor="ctr">
-            <a:normAutofit/>
-          </a:bodyPr>
-          <a:lstStyle/>
-          <a:p>
-            <a:pPr algn="l" indent="0" marL="0">
-              <a:buNone/>
-            </a:pPr>
-            <a:r>
-              <a:rPr lang="en-US" sz="2900" b="1" dirty="0">
-                <a:solidFill>
-                  <a:srgbClr val="0B1F3A"/>
-                </a:solidFill>
-                <a:latin typeface="Arial" pitchFamily="34" charset="0"/>
-                <a:ea typeface="Arial" pitchFamily="34" charset="-122"/>
-                <a:cs typeface="Arial" pitchFamily="34" charset="-120"/>
-              </a:rPr>
-              <a:t>Six specialist components, one optional model draft, and a human decision</a:t>
-            </a:r>
-            <a:endParaRPr lang="en-US" sz="2900" dirty="0"/>
-          </a:p>
-        </p:txBody>
-      </p:sp>
-      <p:sp>
-        <p:nvSpPr>
-          <p:cNvPr id="4" name="Text 2"/>
+      <p:pic>
+        <p:nvPicPr>
+          <p:cNvPr id="2" name="Image 0" descr="C:\D\IIT Mumbai\Capstone Blueprint\assets\walkthrough_screens\2026_data_flow_diagram_v2.svg">    </p:cNvPr>
+          <p:cNvPicPr>
+            <a:picLocks noChangeAspect="1"/>
+          </p:cNvPicPr>
+          <p:nvPr/>
+        </p:nvPicPr>
+        <p:blipFill>
+          <a:blip r:embed="rId1">
+            <a:extLst>
+              <a:ext uri="{96DAC541-7B7A-43D3-8B79-37D633B846F1}">
+                <asvg:svgBlip xmlns:asvg="http://schemas.microsoft.com/office/drawing/2016/SVG/main" r:embed="rId2"/>
+              </a:ext>
+            </a:extLst>
+          </a:blip>
+          <a:stretch>
+            <a:fillRect/>
+          </a:stretch>
+        </p:blipFill>
+        <p:spPr>
+          <a:xfrm>
+            <a:off x="530352" y="219456"/>
+            <a:ext cx="11128248" cy="6263640"/>
+          </a:xfrm>
+          <a:prstGeom prst="rect">
+            <a:avLst/>
+          </a:prstGeom>
+        </p:spPr>
+      </p:pic>
+      <p:sp>
+        <p:nvSpPr>
+          <p:cNvPr id="3" name="Text 0"/>
           <p:cNvSpPr txBox="1"/>
           <p:nvPr/>
         </p:nvSpPr>
@@ -7444,7 +7392,7 @@
       </p:sp>
       <p:sp>
         <p:nvSpPr>
-          <p:cNvPr id="5" name="Text 3"/>
+          <p:cNvPr id="4" name="Text 1"/>
           <p:cNvSpPr txBox="1"/>
           <p:nvPr/>
         </p:nvSpPr>
@@ -7480,1108 +7428,6 @@
               <a:t>Fictional AML investigation learning environment</a:t>
             </a:r>
             <a:endParaRPr lang="en-US" sz="850" dirty="0"/>
-          </a:p>
-        </p:txBody>
-      </p:sp>
-      <p:sp>
-        <p:nvSpPr>
-          <p:cNvPr id="6" name="Shape 4"/>
-          <p:cNvSpPr/>
-          <p:nvPr/>
-        </p:nvSpPr>
-        <p:spPr>
-          <a:xfrm>
-            <a:off x="384048" y="1828800"/>
-            <a:ext cx="2011680" cy="1536192"/>
-          </a:xfrm>
-          <a:prstGeom prst="roundRect">
-            <a:avLst>
-              <a:gd name="adj" fmla="val 7143"/>
-            </a:avLst>
-          </a:prstGeom>
-          <a:solidFill>
-            <a:srgbClr val="FFFFFF"/>
-          </a:solidFill>
-          <a:ln w="12700">
-            <a:solidFill>
-              <a:srgbClr val="FFFFFF">
-                <a:alpha val="0"/>
-              </a:srgbClr>
-            </a:solidFill>
-            <a:prstDash val="solid"/>
-          </a:ln>
-        </p:spPr>
-      </p:sp>
-      <p:sp>
-        <p:nvSpPr>
-          <p:cNvPr id="7" name="Shape 5"/>
-          <p:cNvSpPr/>
-          <p:nvPr/>
-        </p:nvSpPr>
-        <p:spPr>
-          <a:xfrm>
-            <a:off x="548640" y="2029968"/>
-            <a:ext cx="384048" cy="384048"/>
-          </a:xfrm>
-          <a:prstGeom prst="ellipse">
-            <a:avLst/>
-          </a:prstGeom>
-          <a:solidFill>
-            <a:srgbClr val="2E65C5"/>
-          </a:solidFill>
-          <a:ln w="12700">
-            <a:solidFill>
-              <a:srgbClr val="FFFFFF">
-                <a:alpha val="0"/>
-              </a:srgbClr>
-            </a:solidFill>
-            <a:prstDash val="solid"/>
-          </a:ln>
-        </p:spPr>
-      </p:sp>
-      <p:sp>
-        <p:nvSpPr>
-          <p:cNvPr id="8" name="Text 6"/>
-          <p:cNvSpPr txBox="1"/>
-          <p:nvPr/>
-        </p:nvSpPr>
-        <p:spPr>
-          <a:xfrm>
-            <a:off x="548640" y="2130552"/>
-            <a:ext cx="384048" cy="100584"/>
-          </a:xfrm>
-          <a:prstGeom prst="rect">
-            <a:avLst/>
-          </a:prstGeom>
-          <a:noFill/>
-          <a:ln/>
-        </p:spPr>
-        <p:txBody>
-          <a:bodyPr wrap="square" lIns="0" tIns="0" rIns="0" bIns="0" rtlCol="0" anchor="ctr">
-            <a:normAutofit/>
-          </a:bodyPr>
-          <a:lstStyle/>
-          <a:p>
-            <a:pPr algn="ctr" indent="0" marL="0">
-              <a:buNone/>
-            </a:pPr>
-            <a:r>
-              <a:rPr lang="en-US" sz="850" b="1" dirty="0">
-                <a:solidFill>
-                  <a:srgbClr val="FFFFFF"/>
-                </a:solidFill>
-                <a:latin typeface="Arial" pitchFamily="34" charset="0"/>
-                <a:ea typeface="Arial" pitchFamily="34" charset="-122"/>
-                <a:cs typeface="Arial" pitchFamily="34" charset="-120"/>
-              </a:rPr>
-              <a:t>1</a:t>
-            </a:r>
-            <a:endParaRPr lang="en-US" sz="850" dirty="0"/>
-          </a:p>
-        </p:txBody>
-      </p:sp>
-      <p:sp>
-        <p:nvSpPr>
-          <p:cNvPr id="9" name="Text 7"/>
-          <p:cNvSpPr txBox="1"/>
-          <p:nvPr/>
-        </p:nvSpPr>
-        <p:spPr>
-          <a:xfrm>
-            <a:off x="548640" y="2633472"/>
-            <a:ext cx="1627632" cy="292608"/>
-          </a:xfrm>
-          <a:prstGeom prst="rect">
-            <a:avLst/>
-          </a:prstGeom>
-          <a:noFill/>
-          <a:ln/>
-        </p:spPr>
-        <p:txBody>
-          <a:bodyPr wrap="square" lIns="0" tIns="0" rIns="0" bIns="0" rtlCol="0" anchor="t">
-            <a:normAutofit/>
-          </a:bodyPr>
-          <a:lstStyle/>
-          <a:p>
-            <a:pPr algn="l" indent="0" marL="0">
-              <a:buNone/>
-            </a:pPr>
-            <a:r>
-              <a:rPr lang="en-US" sz="1300" b="1" dirty="0">
-                <a:solidFill>
-                  <a:srgbClr val="0B1F3A"/>
-                </a:solidFill>
-                <a:latin typeface="Arial" pitchFamily="34" charset="0"/>
-                <a:ea typeface="Arial" pitchFamily="34" charset="-122"/>
-                <a:cs typeface="Arial" pitchFamily="34" charset="-120"/>
-              </a:rPr>
-              <a:t>Fictional data + index</a:t>
-            </a:r>
-            <a:endParaRPr lang="en-US" sz="1300" dirty="0"/>
-          </a:p>
-        </p:txBody>
-      </p:sp>
-      <p:sp>
-        <p:nvSpPr>
-          <p:cNvPr id="10" name="Text 8"/>
-          <p:cNvSpPr txBox="1"/>
-          <p:nvPr/>
-        </p:nvSpPr>
-        <p:spPr>
-          <a:xfrm>
-            <a:off x="548640" y="3017520"/>
-            <a:ext cx="1664208" cy="256032"/>
-          </a:xfrm>
-          <a:prstGeom prst="rect">
-            <a:avLst/>
-          </a:prstGeom>
-          <a:noFill/>
-          <a:ln/>
-        </p:spPr>
-        <p:txBody>
-          <a:bodyPr wrap="square" lIns="0" tIns="0" rIns="0" bIns="0" rtlCol="0" anchor="t">
-            <a:normAutofit/>
-          </a:bodyPr>
-          <a:lstStyle/>
-          <a:p>
-            <a:pPr algn="l" indent="0" marL="0">
-              <a:buNone/>
-            </a:pPr>
-            <a:r>
-              <a:rPr lang="en-US" sz="940" dirty="0">
-                <a:solidFill>
-                  <a:srgbClr val="63738D"/>
-                </a:solidFill>
-                <a:latin typeface="Arial" pitchFamily="34" charset="0"/>
-                <a:ea typeface="Arial" pitchFamily="34" charset="-122"/>
-                <a:cs typeface="Arial" pitchFamily="34" charset="-120"/>
-              </a:rPr>
-              <a:t>SQLite case rows, OKF guidance, exact chunks, FTS5/BM25</a:t>
-            </a:r>
-            <a:endParaRPr lang="en-US" sz="940" dirty="0"/>
-          </a:p>
-        </p:txBody>
-      </p:sp>
-      <p:sp>
-        <p:nvSpPr>
-          <p:cNvPr id="11" name="Shape 9"/>
-          <p:cNvSpPr/>
-          <p:nvPr/>
-        </p:nvSpPr>
-        <p:spPr>
-          <a:xfrm>
-            <a:off x="2414016" y="2596896"/>
-            <a:ext cx="256032" cy="0"/>
-          </a:xfrm>
-          <a:prstGeom prst="line">
-            <a:avLst/>
-          </a:prstGeom>
-          <a:noFill/>
-          <a:ln w="25400">
-            <a:solidFill>
-              <a:srgbClr val="00A79D"/>
-            </a:solidFill>
-            <a:prstDash val="solid"/>
-            <a:tailEnd type="triangle"/>
-          </a:ln>
-        </p:spPr>
-      </p:sp>
-      <p:sp>
-        <p:nvSpPr>
-          <p:cNvPr id="12" name="Shape 10"/>
-          <p:cNvSpPr/>
-          <p:nvPr/>
-        </p:nvSpPr>
-        <p:spPr>
-          <a:xfrm>
-            <a:off x="2724912" y="1828800"/>
-            <a:ext cx="2011680" cy="1536192"/>
-          </a:xfrm>
-          <a:prstGeom prst="roundRect">
-            <a:avLst>
-              <a:gd name="adj" fmla="val 7143"/>
-            </a:avLst>
-          </a:prstGeom>
-          <a:solidFill>
-            <a:srgbClr val="FFFFFF"/>
-          </a:solidFill>
-          <a:ln w="12700">
-            <a:solidFill>
-              <a:srgbClr val="FFFFFF">
-                <a:alpha val="0"/>
-              </a:srgbClr>
-            </a:solidFill>
-            <a:prstDash val="solid"/>
-          </a:ln>
-        </p:spPr>
-      </p:sp>
-      <p:sp>
-        <p:nvSpPr>
-          <p:cNvPr id="13" name="Shape 11"/>
-          <p:cNvSpPr/>
-          <p:nvPr/>
-        </p:nvSpPr>
-        <p:spPr>
-          <a:xfrm>
-            <a:off x="2889504" y="2029968"/>
-            <a:ext cx="384048" cy="384048"/>
-          </a:xfrm>
-          <a:prstGeom prst="ellipse">
-            <a:avLst/>
-          </a:prstGeom>
-          <a:solidFill>
-            <a:srgbClr val="2E65C5"/>
-          </a:solidFill>
-          <a:ln w="12700">
-            <a:solidFill>
-              <a:srgbClr val="FFFFFF">
-                <a:alpha val="0"/>
-              </a:srgbClr>
-            </a:solidFill>
-            <a:prstDash val="solid"/>
-          </a:ln>
-        </p:spPr>
-      </p:sp>
-      <p:sp>
-        <p:nvSpPr>
-          <p:cNvPr id="14" name="Text 12"/>
-          <p:cNvSpPr txBox="1"/>
-          <p:nvPr/>
-        </p:nvSpPr>
-        <p:spPr>
-          <a:xfrm>
-            <a:off x="2889504" y="2130552"/>
-            <a:ext cx="384048" cy="100584"/>
-          </a:xfrm>
-          <a:prstGeom prst="rect">
-            <a:avLst/>
-          </a:prstGeom>
-          <a:noFill/>
-          <a:ln/>
-        </p:spPr>
-        <p:txBody>
-          <a:bodyPr wrap="square" lIns="0" tIns="0" rIns="0" bIns="0" rtlCol="0" anchor="ctr">
-            <a:normAutofit/>
-          </a:bodyPr>
-          <a:lstStyle/>
-          <a:p>
-            <a:pPr algn="ctr" indent="0" marL="0">
-              <a:buNone/>
-            </a:pPr>
-            <a:r>
-              <a:rPr lang="en-US" sz="850" b="1" dirty="0">
-                <a:solidFill>
-                  <a:srgbClr val="FFFFFF"/>
-                </a:solidFill>
-                <a:latin typeface="Arial" pitchFamily="34" charset="0"/>
-                <a:ea typeface="Arial" pitchFamily="34" charset="-122"/>
-                <a:cs typeface="Arial" pitchFamily="34" charset="-120"/>
-              </a:rPr>
-              <a:t>2</a:t>
-            </a:r>
-            <a:endParaRPr lang="en-US" sz="850" dirty="0"/>
-          </a:p>
-        </p:txBody>
-      </p:sp>
-      <p:sp>
-        <p:nvSpPr>
-          <p:cNvPr id="15" name="Text 13"/>
-          <p:cNvSpPr txBox="1"/>
-          <p:nvPr/>
-        </p:nvSpPr>
-        <p:spPr>
-          <a:xfrm>
-            <a:off x="2889504" y="2633472"/>
-            <a:ext cx="1627632" cy="292608"/>
-          </a:xfrm>
-          <a:prstGeom prst="rect">
-            <a:avLst/>
-          </a:prstGeom>
-          <a:noFill/>
-          <a:ln/>
-        </p:spPr>
-        <p:txBody>
-          <a:bodyPr wrap="square" lIns="0" tIns="0" rIns="0" bIns="0" rtlCol="0" anchor="t">
-            <a:normAutofit/>
-          </a:bodyPr>
-          <a:lstStyle/>
-          <a:p>
-            <a:pPr algn="l" indent="0" marL="0">
-              <a:buNone/>
-            </a:pPr>
-            <a:r>
-              <a:rPr lang="en-US" sz="1300" b="1" dirty="0">
-                <a:solidFill>
-                  <a:srgbClr val="0B1F3A"/>
-                </a:solidFill>
-                <a:latin typeface="Arial" pitchFamily="34" charset="0"/>
-                <a:ea typeface="Arial" pitchFamily="34" charset="-122"/>
-                <a:cs typeface="Arial" pitchFamily="34" charset="-120"/>
-              </a:rPr>
-              <a:t>Specialist workflow</a:t>
-            </a:r>
-            <a:endParaRPr lang="en-US" sz="1300" dirty="0"/>
-          </a:p>
-        </p:txBody>
-      </p:sp>
-      <p:sp>
-        <p:nvSpPr>
-          <p:cNvPr id="16" name="Text 14"/>
-          <p:cNvSpPr txBox="1"/>
-          <p:nvPr/>
-        </p:nvSpPr>
-        <p:spPr>
-          <a:xfrm>
-            <a:off x="2889504" y="3017520"/>
-            <a:ext cx="1664208" cy="256032"/>
-          </a:xfrm>
-          <a:prstGeom prst="rect">
-            <a:avLst/>
-          </a:prstGeom>
-          <a:noFill/>
-          <a:ln/>
-        </p:spPr>
-        <p:txBody>
-          <a:bodyPr wrap="square" lIns="0" tIns="0" rIns="0" bIns="0" rtlCol="0" anchor="t">
-            <a:normAutofit/>
-          </a:bodyPr>
-          <a:lstStyle/>
-          <a:p>
-            <a:pPr algn="l" indent="0" marL="0">
-              <a:buNone/>
-            </a:pPr>
-            <a:r>
-              <a:rPr lang="en-US" sz="940" dirty="0">
-                <a:solidFill>
-                  <a:srgbClr val="63738D"/>
-                </a:solidFill>
-                <a:latin typeface="Arial" pitchFamily="34" charset="0"/>
-                <a:ea typeface="Arial" pitchFamily="34" charset="-122"/>
-                <a:cs typeface="Arial" pitchFamily="34" charset="-120"/>
-              </a:rPr>
-              <a:t>Triage · Customer/KYC · Transactions · Relationships · Evidence</a:t>
-            </a:r>
-            <a:endParaRPr lang="en-US" sz="940" dirty="0"/>
-          </a:p>
-        </p:txBody>
-      </p:sp>
-      <p:sp>
-        <p:nvSpPr>
-          <p:cNvPr id="17" name="Shape 15"/>
-          <p:cNvSpPr/>
-          <p:nvPr/>
-        </p:nvSpPr>
-        <p:spPr>
-          <a:xfrm>
-            <a:off x="4754880" y="2596896"/>
-            <a:ext cx="256032" cy="0"/>
-          </a:xfrm>
-          <a:prstGeom prst="line">
-            <a:avLst/>
-          </a:prstGeom>
-          <a:noFill/>
-          <a:ln w="25400">
-            <a:solidFill>
-              <a:srgbClr val="00A79D"/>
-            </a:solidFill>
-            <a:prstDash val="solid"/>
-            <a:tailEnd type="triangle"/>
-          </a:ln>
-        </p:spPr>
-      </p:sp>
-      <p:sp>
-        <p:nvSpPr>
-          <p:cNvPr id="18" name="Shape 16"/>
-          <p:cNvSpPr/>
-          <p:nvPr/>
-        </p:nvSpPr>
-        <p:spPr>
-          <a:xfrm>
-            <a:off x="5065776" y="1828800"/>
-            <a:ext cx="2011680" cy="1536192"/>
-          </a:xfrm>
-          <a:prstGeom prst="roundRect">
-            <a:avLst>
-              <a:gd name="adj" fmla="val 7143"/>
-            </a:avLst>
-          </a:prstGeom>
-          <a:solidFill>
-            <a:srgbClr val="FFFFFF"/>
-          </a:solidFill>
-          <a:ln w="12700">
-            <a:solidFill>
-              <a:srgbClr val="FFFFFF">
-                <a:alpha val="0"/>
-              </a:srgbClr>
-            </a:solidFill>
-            <a:prstDash val="solid"/>
-          </a:ln>
-        </p:spPr>
-      </p:sp>
-      <p:sp>
-        <p:nvSpPr>
-          <p:cNvPr id="19" name="Shape 17"/>
-          <p:cNvSpPr/>
-          <p:nvPr/>
-        </p:nvSpPr>
-        <p:spPr>
-          <a:xfrm>
-            <a:off x="5230368" y="2029968"/>
-            <a:ext cx="384048" cy="384048"/>
-          </a:xfrm>
-          <a:prstGeom prst="ellipse">
-            <a:avLst/>
-          </a:prstGeom>
-          <a:solidFill>
-            <a:srgbClr val="2E65C5"/>
-          </a:solidFill>
-          <a:ln w="12700">
-            <a:solidFill>
-              <a:srgbClr val="FFFFFF">
-                <a:alpha val="0"/>
-              </a:srgbClr>
-            </a:solidFill>
-            <a:prstDash val="solid"/>
-          </a:ln>
-        </p:spPr>
-      </p:sp>
-      <p:sp>
-        <p:nvSpPr>
-          <p:cNvPr id="20" name="Text 18"/>
-          <p:cNvSpPr txBox="1"/>
-          <p:nvPr/>
-        </p:nvSpPr>
-        <p:spPr>
-          <a:xfrm>
-            <a:off x="5230368" y="2130552"/>
-            <a:ext cx="384048" cy="100584"/>
-          </a:xfrm>
-          <a:prstGeom prst="rect">
-            <a:avLst/>
-          </a:prstGeom>
-          <a:noFill/>
-          <a:ln/>
-        </p:spPr>
-        <p:txBody>
-          <a:bodyPr wrap="square" lIns="0" tIns="0" rIns="0" bIns="0" rtlCol="0" anchor="ctr">
-            <a:normAutofit/>
-          </a:bodyPr>
-          <a:lstStyle/>
-          <a:p>
-            <a:pPr algn="ctr" indent="0" marL="0">
-              <a:buNone/>
-            </a:pPr>
-            <a:r>
-              <a:rPr lang="en-US" sz="850" b="1" dirty="0">
-                <a:solidFill>
-                  <a:srgbClr val="FFFFFF"/>
-                </a:solidFill>
-                <a:latin typeface="Arial" pitchFamily="34" charset="0"/>
-                <a:ea typeface="Arial" pitchFamily="34" charset="-122"/>
-                <a:cs typeface="Arial" pitchFamily="34" charset="-120"/>
-              </a:rPr>
-              <a:t>3</a:t>
-            </a:r>
-            <a:endParaRPr lang="en-US" sz="850" dirty="0"/>
-          </a:p>
-        </p:txBody>
-      </p:sp>
-      <p:sp>
-        <p:nvSpPr>
-          <p:cNvPr id="21" name="Text 19"/>
-          <p:cNvSpPr txBox="1"/>
-          <p:nvPr/>
-        </p:nvSpPr>
-        <p:spPr>
-          <a:xfrm>
-            <a:off x="5230368" y="2633472"/>
-            <a:ext cx="1627632" cy="292608"/>
-          </a:xfrm>
-          <a:prstGeom prst="rect">
-            <a:avLst/>
-          </a:prstGeom>
-          <a:noFill/>
-          <a:ln/>
-        </p:spPr>
-        <p:txBody>
-          <a:bodyPr wrap="square" lIns="0" tIns="0" rIns="0" bIns="0" rtlCol="0" anchor="t">
-            <a:normAutofit/>
-          </a:bodyPr>
-          <a:lstStyle/>
-          <a:p>
-            <a:pPr algn="l" indent="0" marL="0">
-              <a:buNone/>
-            </a:pPr>
-            <a:r>
-              <a:rPr lang="en-US" sz="1300" b="1" dirty="0">
-                <a:solidFill>
-                  <a:srgbClr val="0B1F3A"/>
-                </a:solidFill>
-                <a:latin typeface="Arial" pitchFamily="34" charset="0"/>
-                <a:ea typeface="Arial" pitchFamily="34" charset="-122"/>
-                <a:cs typeface="Arial" pitchFamily="34" charset="-120"/>
-              </a:rPr>
-              <a:t>Summary draft</a:t>
-            </a:r>
-            <a:endParaRPr lang="en-US" sz="1300" dirty="0"/>
-          </a:p>
-        </p:txBody>
-      </p:sp>
-      <p:sp>
-        <p:nvSpPr>
-          <p:cNvPr id="22" name="Text 20"/>
-          <p:cNvSpPr txBox="1"/>
-          <p:nvPr/>
-        </p:nvSpPr>
-        <p:spPr>
-          <a:xfrm>
-            <a:off x="5230368" y="3017520"/>
-            <a:ext cx="1664208" cy="256032"/>
-          </a:xfrm>
-          <a:prstGeom prst="rect">
-            <a:avLst/>
-          </a:prstGeom>
-          <a:noFill/>
-          <a:ln/>
-        </p:spPr>
-        <p:txBody>
-          <a:bodyPr wrap="square" lIns="0" tIns="0" rIns="0" bIns="0" rtlCol="0" anchor="t">
-            <a:normAutofit/>
-          </a:bodyPr>
-          <a:lstStyle/>
-          <a:p>
-            <a:pPr algn="l" indent="0" marL="0">
-              <a:buNone/>
-            </a:pPr>
-            <a:r>
-              <a:rPr lang="en-US" sz="940" dirty="0">
-                <a:solidFill>
-                  <a:srgbClr val="63738D"/>
-                </a:solidFill>
-                <a:latin typeface="Arial" pitchFamily="34" charset="0"/>
-                <a:ea typeface="Arial" pitchFamily="34" charset="-122"/>
-                <a:cs typeface="Arial" pitchFamily="34" charset="-120"/>
-              </a:rPr>
-              <a:t>Investigation Summary Agent; optional Gemini call or calculated mode</a:t>
-            </a:r>
-            <a:endParaRPr lang="en-US" sz="940" dirty="0"/>
-          </a:p>
-        </p:txBody>
-      </p:sp>
-      <p:sp>
-        <p:nvSpPr>
-          <p:cNvPr id="23" name="Shape 21"/>
-          <p:cNvSpPr/>
-          <p:nvPr/>
-        </p:nvSpPr>
-        <p:spPr>
-          <a:xfrm>
-            <a:off x="7095744" y="2596896"/>
-            <a:ext cx="256032" cy="0"/>
-          </a:xfrm>
-          <a:prstGeom prst="line">
-            <a:avLst/>
-          </a:prstGeom>
-          <a:noFill/>
-          <a:ln w="25400">
-            <a:solidFill>
-              <a:srgbClr val="00A79D"/>
-            </a:solidFill>
-            <a:prstDash val="solid"/>
-            <a:tailEnd type="triangle"/>
-          </a:ln>
-        </p:spPr>
-      </p:sp>
-      <p:sp>
-        <p:nvSpPr>
-          <p:cNvPr id="24" name="Shape 22"/>
-          <p:cNvSpPr/>
-          <p:nvPr/>
-        </p:nvSpPr>
-        <p:spPr>
-          <a:xfrm>
-            <a:off x="7406640" y="1828800"/>
-            <a:ext cx="2011680" cy="1536192"/>
-          </a:xfrm>
-          <a:prstGeom prst="roundRect">
-            <a:avLst>
-              <a:gd name="adj" fmla="val 7143"/>
-            </a:avLst>
-          </a:prstGeom>
-          <a:solidFill>
-            <a:srgbClr val="E6F8F6"/>
-          </a:solidFill>
-          <a:ln w="12700">
-            <a:solidFill>
-              <a:srgbClr val="E6F8F6">
-                <a:alpha val="0"/>
-              </a:srgbClr>
-            </a:solidFill>
-            <a:prstDash val="solid"/>
-          </a:ln>
-        </p:spPr>
-      </p:sp>
-      <p:sp>
-        <p:nvSpPr>
-          <p:cNvPr id="25" name="Shape 23"/>
-          <p:cNvSpPr/>
-          <p:nvPr/>
-        </p:nvSpPr>
-        <p:spPr>
-          <a:xfrm>
-            <a:off x="7571232" y="2029968"/>
-            <a:ext cx="384048" cy="384048"/>
-          </a:xfrm>
-          <a:prstGeom prst="ellipse">
-            <a:avLst/>
-          </a:prstGeom>
-          <a:solidFill>
-            <a:srgbClr val="00A79D"/>
-          </a:solidFill>
-          <a:ln w="12700">
-            <a:solidFill>
-              <a:srgbClr val="FFFFFF">
-                <a:alpha val="0"/>
-              </a:srgbClr>
-            </a:solidFill>
-            <a:prstDash val="solid"/>
-          </a:ln>
-        </p:spPr>
-      </p:sp>
-      <p:sp>
-        <p:nvSpPr>
-          <p:cNvPr id="26" name="Text 24"/>
-          <p:cNvSpPr txBox="1"/>
-          <p:nvPr/>
-        </p:nvSpPr>
-        <p:spPr>
-          <a:xfrm>
-            <a:off x="7571232" y="2130552"/>
-            <a:ext cx="384048" cy="100584"/>
-          </a:xfrm>
-          <a:prstGeom prst="rect">
-            <a:avLst/>
-          </a:prstGeom>
-          <a:noFill/>
-          <a:ln/>
-        </p:spPr>
-        <p:txBody>
-          <a:bodyPr wrap="square" lIns="0" tIns="0" rIns="0" bIns="0" rtlCol="0" anchor="ctr">
-            <a:normAutofit/>
-          </a:bodyPr>
-          <a:lstStyle/>
-          <a:p>
-            <a:pPr algn="ctr" indent="0" marL="0">
-              <a:buNone/>
-            </a:pPr>
-            <a:r>
-              <a:rPr lang="en-US" sz="850" b="1" dirty="0">
-                <a:solidFill>
-                  <a:srgbClr val="FFFFFF"/>
-                </a:solidFill>
-                <a:latin typeface="Arial" pitchFamily="34" charset="0"/>
-                <a:ea typeface="Arial" pitchFamily="34" charset="-122"/>
-                <a:cs typeface="Arial" pitchFamily="34" charset="-120"/>
-              </a:rPr>
-              <a:t>4</a:t>
-            </a:r>
-            <a:endParaRPr lang="en-US" sz="850" dirty="0"/>
-          </a:p>
-        </p:txBody>
-      </p:sp>
-      <p:sp>
-        <p:nvSpPr>
-          <p:cNvPr id="27" name="Text 25"/>
-          <p:cNvSpPr txBox="1"/>
-          <p:nvPr/>
-        </p:nvSpPr>
-        <p:spPr>
-          <a:xfrm>
-            <a:off x="7571232" y="2633472"/>
-            <a:ext cx="1627632" cy="292608"/>
-          </a:xfrm>
-          <a:prstGeom prst="rect">
-            <a:avLst/>
-          </a:prstGeom>
-          <a:noFill/>
-          <a:ln/>
-        </p:spPr>
-        <p:txBody>
-          <a:bodyPr wrap="square" lIns="0" tIns="0" rIns="0" bIns="0" rtlCol="0" anchor="t">
-            <a:normAutofit/>
-          </a:bodyPr>
-          <a:lstStyle/>
-          <a:p>
-            <a:pPr algn="l" indent="0" marL="0">
-              <a:buNone/>
-            </a:pPr>
-            <a:r>
-              <a:rPr lang="en-US" sz="1300" b="1" dirty="0">
-                <a:solidFill>
-                  <a:srgbClr val="0B1F3A"/>
-                </a:solidFill>
-                <a:latin typeface="Arial" pitchFamily="34" charset="0"/>
-                <a:ea typeface="Arial" pitchFamily="34" charset="-122"/>
-                <a:cs typeface="Arial" pitchFamily="34" charset="-120"/>
-              </a:rPr>
-              <a:t>Grounding Validator</a:t>
-            </a:r>
-            <a:endParaRPr lang="en-US" sz="1300" dirty="0"/>
-          </a:p>
-        </p:txBody>
-      </p:sp>
-      <p:sp>
-        <p:nvSpPr>
-          <p:cNvPr id="28" name="Text 26"/>
-          <p:cNvSpPr txBox="1"/>
-          <p:nvPr/>
-        </p:nvSpPr>
-        <p:spPr>
-          <a:xfrm>
-            <a:off x="7571232" y="3017520"/>
-            <a:ext cx="1664208" cy="256032"/>
-          </a:xfrm>
-          <a:prstGeom prst="rect">
-            <a:avLst/>
-          </a:prstGeom>
-          <a:noFill/>
-          <a:ln/>
-        </p:spPr>
-        <p:txBody>
-          <a:bodyPr wrap="square" lIns="0" tIns="0" rIns="0" bIns="0" rtlCol="0" anchor="t">
-            <a:normAutofit/>
-          </a:bodyPr>
-          <a:lstStyle/>
-          <a:p>
-            <a:pPr algn="l" indent="0" marL="0">
-              <a:buNone/>
-            </a:pPr>
-            <a:r>
-              <a:rPr lang="en-US" sz="940" dirty="0">
-                <a:solidFill>
-                  <a:srgbClr val="63738D"/>
-                </a:solidFill>
-                <a:latin typeface="Arial" pitchFamily="34" charset="0"/>
-                <a:ea typeface="Arial" pitchFamily="34" charset="-122"/>
-                <a:cs typeface="Arial" pitchFamily="34" charset="-120"/>
-              </a:rPr>
-              <a:t>Checks cited IDs, selected ratios, forbidden verdict wording, prompt-like text</a:t>
-            </a:r>
-            <a:endParaRPr lang="en-US" sz="940" dirty="0"/>
-          </a:p>
-        </p:txBody>
-      </p:sp>
-      <p:sp>
-        <p:nvSpPr>
-          <p:cNvPr id="29" name="Shape 27"/>
-          <p:cNvSpPr/>
-          <p:nvPr/>
-        </p:nvSpPr>
-        <p:spPr>
-          <a:xfrm>
-            <a:off x="9436608" y="2596896"/>
-            <a:ext cx="256032" cy="0"/>
-          </a:xfrm>
-          <a:prstGeom prst="line">
-            <a:avLst/>
-          </a:prstGeom>
-          <a:noFill/>
-          <a:ln w="25400">
-            <a:solidFill>
-              <a:srgbClr val="00A79D"/>
-            </a:solidFill>
-            <a:prstDash val="solid"/>
-            <a:tailEnd type="triangle"/>
-          </a:ln>
-        </p:spPr>
-      </p:sp>
-      <p:sp>
-        <p:nvSpPr>
-          <p:cNvPr id="30" name="Shape 28"/>
-          <p:cNvSpPr/>
-          <p:nvPr/>
-        </p:nvSpPr>
-        <p:spPr>
-          <a:xfrm>
-            <a:off x="9747504" y="1828800"/>
-            <a:ext cx="2011680" cy="1536192"/>
-          </a:xfrm>
-          <a:prstGeom prst="roundRect">
-            <a:avLst>
-              <a:gd name="adj" fmla="val 7143"/>
-            </a:avLst>
-          </a:prstGeom>
-          <a:solidFill>
-            <a:srgbClr val="FFFFFF"/>
-          </a:solidFill>
-          <a:ln w="12700">
-            <a:solidFill>
-              <a:srgbClr val="FFFFFF">
-                <a:alpha val="0"/>
-              </a:srgbClr>
-            </a:solidFill>
-            <a:prstDash val="solid"/>
-          </a:ln>
-        </p:spPr>
-      </p:sp>
-      <p:sp>
-        <p:nvSpPr>
-          <p:cNvPr id="31" name="Shape 29"/>
-          <p:cNvSpPr/>
-          <p:nvPr/>
-        </p:nvSpPr>
-        <p:spPr>
-          <a:xfrm>
-            <a:off x="9912096" y="2029968"/>
-            <a:ext cx="384048" cy="384048"/>
-          </a:xfrm>
-          <a:prstGeom prst="ellipse">
-            <a:avLst/>
-          </a:prstGeom>
-          <a:solidFill>
-            <a:srgbClr val="2E65C5"/>
-          </a:solidFill>
-          <a:ln w="12700">
-            <a:solidFill>
-              <a:srgbClr val="FFFFFF">
-                <a:alpha val="0"/>
-              </a:srgbClr>
-            </a:solidFill>
-            <a:prstDash val="solid"/>
-          </a:ln>
-        </p:spPr>
-      </p:sp>
-      <p:sp>
-        <p:nvSpPr>
-          <p:cNvPr id="32" name="Text 30"/>
-          <p:cNvSpPr txBox="1"/>
-          <p:nvPr/>
-        </p:nvSpPr>
-        <p:spPr>
-          <a:xfrm>
-            <a:off x="9912096" y="2130552"/>
-            <a:ext cx="384048" cy="100584"/>
-          </a:xfrm>
-          <a:prstGeom prst="rect">
-            <a:avLst/>
-          </a:prstGeom>
-          <a:noFill/>
-          <a:ln/>
-        </p:spPr>
-        <p:txBody>
-          <a:bodyPr wrap="square" lIns="0" tIns="0" rIns="0" bIns="0" rtlCol="0" anchor="ctr">
-            <a:normAutofit/>
-          </a:bodyPr>
-          <a:lstStyle/>
-          <a:p>
-            <a:pPr algn="ctr" indent="0" marL="0">
-              <a:buNone/>
-            </a:pPr>
-            <a:r>
-              <a:rPr lang="en-US" sz="850" b="1" dirty="0">
-                <a:solidFill>
-                  <a:srgbClr val="FFFFFF"/>
-                </a:solidFill>
-                <a:latin typeface="Arial" pitchFamily="34" charset="0"/>
-                <a:ea typeface="Arial" pitchFamily="34" charset="-122"/>
-                <a:cs typeface="Arial" pitchFamily="34" charset="-120"/>
-              </a:rPr>
-              <a:t>5</a:t>
-            </a:r>
-            <a:endParaRPr lang="en-US" sz="850" dirty="0"/>
-          </a:p>
-        </p:txBody>
-      </p:sp>
-      <p:sp>
-        <p:nvSpPr>
-          <p:cNvPr id="33" name="Text 31"/>
-          <p:cNvSpPr txBox="1"/>
-          <p:nvPr/>
-        </p:nvSpPr>
-        <p:spPr>
-          <a:xfrm>
-            <a:off x="9912096" y="2633472"/>
-            <a:ext cx="1627632" cy="292608"/>
-          </a:xfrm>
-          <a:prstGeom prst="rect">
-            <a:avLst/>
-          </a:prstGeom>
-          <a:noFill/>
-          <a:ln/>
-        </p:spPr>
-        <p:txBody>
-          <a:bodyPr wrap="square" lIns="0" tIns="0" rIns="0" bIns="0" rtlCol="0" anchor="t">
-            <a:normAutofit/>
-          </a:bodyPr>
-          <a:lstStyle/>
-          <a:p>
-            <a:pPr algn="l" indent="0" marL="0">
-              <a:buNone/>
-            </a:pPr>
-            <a:r>
-              <a:rPr lang="en-US" sz="1300" b="1" dirty="0">
-                <a:solidFill>
-                  <a:srgbClr val="0B1F3A"/>
-                </a:solidFill>
-                <a:latin typeface="Arial" pitchFamily="34" charset="0"/>
-                <a:ea typeface="Arial" pitchFamily="34" charset="-122"/>
-                <a:cs typeface="Arial" pitchFamily="34" charset="-120"/>
-              </a:rPr>
-              <a:t>Human + audit</a:t>
-            </a:r>
-            <a:endParaRPr lang="en-US" sz="1300" dirty="0"/>
-          </a:p>
-        </p:txBody>
-      </p:sp>
-      <p:sp>
-        <p:nvSpPr>
-          <p:cNvPr id="34" name="Text 32"/>
-          <p:cNvSpPr txBox="1"/>
-          <p:nvPr/>
-        </p:nvSpPr>
-        <p:spPr>
-          <a:xfrm>
-            <a:off x="9912096" y="3017520"/>
-            <a:ext cx="1664208" cy="256032"/>
-          </a:xfrm>
-          <a:prstGeom prst="rect">
-            <a:avLst/>
-          </a:prstGeom>
-          <a:noFill/>
-          <a:ln/>
-        </p:spPr>
-        <p:txBody>
-          <a:bodyPr wrap="square" lIns="0" tIns="0" rIns="0" bIns="0" rtlCol="0" anchor="t">
-            <a:normAutofit/>
-          </a:bodyPr>
-          <a:lstStyle/>
-          <a:p>
-            <a:pPr algn="l" indent="0" marL="0">
-              <a:buNone/>
-            </a:pPr>
-            <a:r>
-              <a:rPr lang="en-US" sz="940" dirty="0">
-                <a:solidFill>
-                  <a:srgbClr val="63738D"/>
-                </a:solidFill>
-                <a:latin typeface="Arial" pitchFamily="34" charset="0"/>
-                <a:ea typeface="Arial" pitchFamily="34" charset="-122"/>
-                <a:cs typeface="Arial" pitchFamily="34" charset="-120"/>
-              </a:rPr>
-              <a:t>Named rationale; append-only audit event; separate Compliance review</a:t>
-            </a:r>
-            <a:endParaRPr lang="en-US" sz="940" dirty="0"/>
-          </a:p>
-        </p:txBody>
-      </p:sp>
-      <p:sp>
-        <p:nvSpPr>
-          <p:cNvPr id="35" name="Shape 33"/>
-          <p:cNvSpPr/>
-          <p:nvPr/>
-        </p:nvSpPr>
-        <p:spPr>
-          <a:xfrm>
-            <a:off x="685800" y="4069080"/>
-            <a:ext cx="10817352" cy="777240"/>
-          </a:xfrm>
-          <a:prstGeom prst="roundRect">
-            <a:avLst>
-              <a:gd name="adj" fmla="val 14118"/>
-            </a:avLst>
-          </a:prstGeom>
-          <a:solidFill>
-            <a:srgbClr val="173C78"/>
-          </a:solidFill>
-          <a:ln w="12700">
-            <a:solidFill>
-              <a:srgbClr val="173C78">
-                <a:alpha val="0"/>
-              </a:srgbClr>
-            </a:solidFill>
-            <a:prstDash val="solid"/>
-          </a:ln>
-        </p:spPr>
-      </p:sp>
-      <p:sp>
-        <p:nvSpPr>
-          <p:cNvPr id="36" name="Text 34"/>
-          <p:cNvSpPr txBox="1"/>
-          <p:nvPr/>
-        </p:nvSpPr>
-        <p:spPr>
-          <a:xfrm>
-            <a:off x="914400" y="4279392"/>
-            <a:ext cx="10360152" cy="329184"/>
-          </a:xfrm>
-          <a:prstGeom prst="rect">
-            <a:avLst/>
-          </a:prstGeom>
-          <a:noFill/>
-          <a:ln/>
-        </p:spPr>
-        <p:txBody>
-          <a:bodyPr wrap="square" lIns="0" tIns="0" rIns="0" bIns="0" rtlCol="0" anchor="t">
-            <a:normAutofit/>
-          </a:bodyPr>
-          <a:lstStyle/>
-          <a:p>
-            <a:pPr algn="ctr" indent="0" marL="0">
-              <a:buNone/>
-            </a:pPr>
-            <a:r>
-              <a:rPr lang="en-US" sz="1300" b="1" dirty="0">
-                <a:solidFill>
-                  <a:srgbClr val="FFFFFF"/>
-                </a:solidFill>
-                <a:latin typeface="Arial" pitchFamily="34" charset="0"/>
-                <a:ea typeface="Arial" pitchFamily="34" charset="-122"/>
-                <a:cs typeface="Arial" pitchFamily="34" charset="-120"/>
-              </a:rPr>
-              <a:t>Where AI is used: the Investigation Summary Agent drafts a structured report only after the deterministic specialist components retrieve and calculate evidence. The Grounding Validator then checks selected claims before a human can act.</a:t>
-            </a:r>
-            <a:endParaRPr lang="en-US" sz="1300" dirty="0"/>
-          </a:p>
-        </p:txBody>
-      </p:sp>
-      <p:sp>
-        <p:nvSpPr>
-          <p:cNvPr id="37" name="Text 35"/>
-          <p:cNvSpPr txBox="1"/>
-          <p:nvPr/>
-        </p:nvSpPr>
-        <p:spPr>
-          <a:xfrm>
-            <a:off x="777240" y="5166360"/>
-            <a:ext cx="10607040" cy="219456"/>
-          </a:xfrm>
-          <a:prstGeom prst="rect">
-            <a:avLst/>
-          </a:prstGeom>
-          <a:noFill/>
-          <a:ln/>
-        </p:spPr>
-        <p:txBody>
-          <a:bodyPr wrap="square" lIns="0" tIns="0" rIns="0" bIns="0" rtlCol="0" anchor="ctr">
-            <a:normAutofit/>
-          </a:bodyPr>
-          <a:lstStyle/>
-          <a:p>
-            <a:pPr algn="ctr" indent="0" marL="0">
-              <a:buNone/>
-            </a:pPr>
-            <a:r>
-              <a:rPr lang="en-US" sz="1150" i="1" dirty="0">
-                <a:solidFill>
-                  <a:srgbClr val="63738D"/>
-                </a:solidFill>
-                <a:latin typeface="Arial" pitchFamily="34" charset="0"/>
-                <a:ea typeface="Arial" pitchFamily="34" charset="-122"/>
-                <a:cs typeface="Arial" pitchFamily="34" charset="-120"/>
-              </a:rPr>
-              <a:t>Important: these are investigation-specialist components—not CEO/CFO persona agents. The validator reduces specific errors; it cannot guarantee factual truth.</a:t>
-            </a:r>
-            <a:endParaRPr lang="en-US" sz="1150" dirty="0"/>
           </a:p>
         </p:txBody>
       </p:sp>

</xml_diff>